<commit_message>
Fact-check fixes, contribution statement, refreshed dashboard
- Correct figures found in a fact-check: stuck sensor ran 16 days
  (24 Aug - 8 Sep 2019), Shillong reading 918 ug/m3, hourly files 285 MB,
  Model B pre-lockdown R2 0.67, fact table 61 columns
- Rename the data-quality KPI to "Days with bad PM data" and re-save the
  pbix and its PDF export
- Add docs/contribution_statement.txt and update the report and deck
  contribution sections
- Re-run the notebook end to end (0 errors)

Co-Authored-By: Claude Opus 5.5 <noreply@anthropic.com>
</commit_message>
<xml_diff>
--- a/docs/presentation/Breathe_India_viva.pptx
+++ b/docs/presentation/Breathe_India_viva.pptx
@@ -1880,7 +1880,7 @@
           <a:lstStyle/>
           <a:p>
             <a:r>
-              <a:t>These are the four ways the raw data misled us. One: Ahmedabad's carbon monoxide column is a copy of its nitric oxide column, identical on 94 percent of days. Two: on 256 days fine particles exceeded coarse particles, which is physically impossible. We first assumed the PM10 sensor was wrong; the data told us it was PM2.5, so we changed our rule. Three: broken sensors, including Shillong 'reading' 917. Four: impossible AQI values and big gaps. Every decision, 23 in all, is in our cleaning log with its reason.</a:t>
+              <a:t>These are the four ways the raw data misled us. One: Ahmedabad's carbon monoxide column is a copy of its nitric oxide column, identical on 94 percent of days. Two: on 256 days fine particles exceeded coarse particles, which is physically impossible. We first assumed the PM10 sensor was wrong; the data told us it was PM2.5, so we changed our rule. Three: broken sensors, including Shillong 'reading' 918. Four: impossible AQI values and big gaps. Every decision, 23 in all, is in our cleaning log with its reason.</a:t>
             </a:r>
           </a:p>
         </p:txBody>
@@ -6186,7 +6186,7 @@
                 </a:solidFill>
                 <a:latin typeface="Calibri"/>
               </a:rPr>
-              <a:t>Mahak led extraction, cleaning and storage; Yash led transformation, the models and the dashboard; insights, report and deck together.</a:t>
+              <a:t>Mahak led transformation, the models and the dashboard; Yash led extraction, cleaning and storage; insights, report and deck together.</a:t>
             </a:r>
           </a:p>
         </p:txBody>
@@ -7336,7 +7336,7 @@
                 </a:solidFill>
                 <a:latin typeface="Calibri"/>
               </a:rPr>
-              <a:t>52,234 days of ERA5 weather · rate-limited, cached</a:t>
+              <a:t>52,234 city-days of ERA5 weather · rate-limited, cached</a:t>
             </a:r>
           </a:p>
         </p:txBody>
@@ -7831,7 +7831,7 @@
                 </a:solidFill>
                 <a:latin typeface="Calibri"/>
               </a:rPr>
-              <a:t>28,260 city-days × 62 columns</a:t>
+              <a:t>28,260 city-days × 61 columns</a:t>
             </a:r>
           </a:p>
           <a:p>
@@ -9306,7 +9306,7 @@
                 </a:solidFill>
                 <a:latin typeface="Calibri"/>
               </a:rPr>
-              <a:t>A sensor stuck at 11.00 for 8 days, and 917 µg/m³ in Shillong, the cleanest city. 197 readings removed, with Diwali spikes kept.</a:t>
+              <a:t>A sensor stuck at 11.00 for 16 days, and 918 µg/m³ in Shillong, the cleanest city. 197 readings removed, with Diwali spikes kept.</a:t>
             </a:r>
           </a:p>
         </p:txBody>

</xml_diff>